<commit_message>
updated pptx and added presentation slides, added spark declarative integration, added decorator quickstart example, added spark declarative quickstart example, added test cases for decorators and spark declarative, updated README.md with new content and images, added .DS_Store files to be committed (should be ignored in future commits)
</commit_message>
<xml_diff>
--- a/presentation/kage_5min.pptx
+++ b/presentation/kage_5min.pptx
@@ -11,6 +11,7 @@
     <p:sldId id="259" r:id="rId11"/>
     <p:sldId id="260" r:id="rId12"/>
     <p:sldId id="261" r:id="rId13"/>
+    <p:sldId id="262" r:id="rId14"/>
   </p:sldIdLst>
   <p:sldSz cx="12191695" cy="6858000" type="screen4x3"/>
   <p:notesSz cx="6858000" cy="9144000"/>
@@ -1348,6 +1349,197 @@
           <a:p>
             <a:r>
               <a:t>  `dataset_write` / `job_start` calls — KAGE writes additive events.</a:t>
+            </a:r>
+          </a:p>
+          <a:p/>
+        </p:txBody>
+      </p:sp>
+      <p:sp>
+        <p:nvSpPr>
+          <p:cNvPr id="4" name="Slide Number Placeholder 3"/>
+          <p:cNvSpPr>
+            <a:spLocks noGrp="1"/>
+          </p:cNvSpPr>
+          <p:nvPr>
+            <p:ph type="sldNum" idx="5" sz="quarter"/>
+          </p:nvPr>
+        </p:nvSpPr>
+        <p:spPr/>
+      </p:sp>
+    </p:spTree>
+  </p:cSld>
+  <p:clrMapOvr>
+    <a:masterClrMapping/>
+  </p:clrMapOvr>
+</p:notes>
+</file>
+
+<file path=ppt/notesSlides/notesSlide7.xml><?xml version="1.0" encoding="utf-8"?>
+<p:notes xmlns:a="http://schemas.openxmlformats.org/drawingml/2006/main" xmlns:p="http://schemas.openxmlformats.org/presentationml/2006/main" xmlns:r="http://schemas.openxmlformats.org/officeDocument/2006/relationships">
+  <p:cSld>
+    <p:spTree>
+      <p:nvGrpSpPr>
+        <p:cNvPr id="1" name=""/>
+        <p:cNvGrpSpPr/>
+        <p:nvPr/>
+      </p:nvGrpSpPr>
+      <p:grpSpPr>
+        <a:xfrm>
+          <a:off x="0" y="0"/>
+          <a:ext cx="0" cy="0"/>
+          <a:chOff x="0" y="0"/>
+          <a:chExt cx="0" cy="0"/>
+        </a:xfrm>
+      </p:grpSpPr>
+      <p:sp>
+        <p:nvSpPr>
+          <p:cNvPr id="2" name="Slide Image Placeholder 1"/>
+          <p:cNvSpPr>
+            <a:spLocks noGrp="1"/>
+          </p:cNvSpPr>
+          <p:nvPr>
+            <p:ph type="sldImg" idx="2"/>
+          </p:nvPr>
+        </p:nvSpPr>
+        <p:spPr/>
+      </p:sp>
+      <p:sp>
+        <p:nvSpPr>
+          <p:cNvPr id="3" name="Notes Placeholder 2"/>
+          <p:cNvSpPr>
+            <a:spLocks noGrp="1"/>
+          </p:cNvSpPr>
+          <p:nvPr>
+            <p:ph type="body" idx="3" sz="quarter"/>
+          </p:nvPr>
+        </p:nvSpPr>
+        <p:spPr/>
+        <p:txBody>
+          <a:bodyPr/>
+          <a:lstStyle/>
+          <a:p>
+            <a:r>
+              <a:t># Slide 7 — Backup: KAGE × Databricks (skip unless asked)</a:t>
+            </a:r>
+          </a:p>
+          <a:p/>
+          <a:p>
+            <a:r>
+              <a:t>## When to show this slide</a:t>
+            </a:r>
+          </a:p>
+          <a:p>
+            <a:r>
+              <a:t>Only when someone asks "how is this different from what Databricks already gives me?"</a:t>
+            </a:r>
+          </a:p>
+          <a:p>
+            <a:r>
+              <a:t>Do NOT run through this in the 5-minute slot — it eats your buffer.</a:t>
+            </a:r>
+          </a:p>
+          <a:p/>
+          <a:p>
+            <a:r>
+              <a:t>## Framing (open with this)</a:t>
+            </a:r>
+          </a:p>
+          <a:p>
+            <a:r>
+              <a:t>&gt; "KAGE doesn't replace Databricks observability. It gives you the **same</a:t>
+            </a:r>
+          </a:p>
+          <a:p>
+            <a:r>
+              <a:t>&gt; lens across every platform you run** — Databricks, Snowflake, on-prem</a:t>
+            </a:r>
+          </a:p>
+          <a:p>
+            <a:r>
+              <a:t>&gt; Spark, dbt, Airflow — with medallion semantics, business custom fields,</a:t>
+            </a:r>
+          </a:p>
+          <a:p>
+            <a:r>
+              <a:t>&gt; and AI-suggested fixes built in."</a:t>
+            </a:r>
+          </a:p>
+          <a:p/>
+          <a:p>
+            <a:r>
+              <a:t>## Talking points (pick 2–3 based on the questioner)</a:t>
+            </a:r>
+          </a:p>
+          <a:p>
+            <a:r>
+              <a:t>- **Cross-platform schema** — same JSONL contract everywhere; one SQL spans all clouds.</a:t>
+            </a:r>
+          </a:p>
+          <a:p>
+            <a:r>
+              <a:t>- **Medallion semantics** — `layer` is a first-class column; gold survival % is a direct query, not a derivation.</a:t>
+            </a:r>
+          </a:p>
+          <a:p>
+            <a:r>
+              <a:t>- **You own the data** — JSONL in your Volume / S3 / ADLS; export and retention are yours, not Databricks'.</a:t>
+            </a:r>
+          </a:p>
+          <a:p>
+            <a:r>
+              <a:t>- **Custom business fields** — owner, SLA, cost center attach to every event.</a:t>
+            </a:r>
+          </a:p>
+          <a:p>
+            <a:r>
+              <a:t>- **Lineage outside Databricks** — Python/dbt/Airflow code emits `upstream_datasets`; Unity Catalog can't see those today.</a:t>
+            </a:r>
+          </a:p>
+          <a:p>
+            <a:r>
+              <a:t>- **AI suggestions** — every analytics query takes `model_name=…` and tacks on an `ai_query()` column with remediation per row.</a:t>
+            </a:r>
+          </a:p>
+          <a:p/>
+          <a:p>
+            <a:r>
+              <a:t>## Be honest about overlap (volunteer this)</a:t>
+            </a:r>
+          </a:p>
+          <a:p>
+            <a:r>
+              <a:t>- Column-level lineage *inside* Databricks → Unity Catalog wins, KAGE doesn't replace this.</a:t>
+            </a:r>
+          </a:p>
+          <a:p>
+            <a:r>
+              <a:t>- Lakehouse Monitoring covers profile / quality drift; KAGE's schema-drift query overlaps.</a:t>
+            </a:r>
+          </a:p>
+          <a:p>
+            <a:r>
+              <a:t>- Jobs UI shows job-level success/failure already — KAGE's value is making it cross-platform queryable.</a:t>
+            </a:r>
+          </a:p>
+          <a:p/>
+          <a:p>
+            <a:r>
+              <a:t>## Closing line (after they're convinced)</a:t>
+            </a:r>
+          </a:p>
+          <a:p>
+            <a:r>
+              <a:t>&gt; "Think of KAGE as the **glue** that makes Databricks observability portable</a:t>
+            </a:r>
+          </a:p>
+          <a:p>
+            <a:r>
+              <a:t>&gt; to the rest of your stack — and as the place to put your *business* context</a:t>
+            </a:r>
+          </a:p>
+          <a:p>
+            <a:r>
+              <a:t>&gt; next to the Databricks platform context."</a:t>
             </a:r>
           </a:p>
           <a:p/>
@@ -4414,8 +4606,8 @@
         </p:nvSpPr>
         <p:spPr>
           <a:xfrm>
-            <a:off x="11338560" y="6492240"/>
-            <a:ext cx="731520" cy="274320"/>
+            <a:off x="11155680" y="6492240"/>
+            <a:ext cx="914400" cy="274320"/>
           </a:xfrm>
           <a:prstGeom prst="rect">
             <a:avLst/>
@@ -4436,7 +4628,7 @@
                 </a:solidFill>
                 <a:latin typeface="Calibri"/>
               </a:rPr>
-              <a:t>1 / 6</a:t>
+              <a:t>1 / 7</a:t>
             </a:r>
           </a:p>
         </p:txBody>
@@ -4748,8 +4940,8 @@
         </p:nvSpPr>
         <p:spPr>
           <a:xfrm>
-            <a:off x="11338560" y="6492240"/>
-            <a:ext cx="731520" cy="274320"/>
+            <a:off x="11155680" y="6492240"/>
+            <a:ext cx="914400" cy="274320"/>
           </a:xfrm>
           <a:prstGeom prst="rect">
             <a:avLst/>
@@ -4770,7 +4962,7 @@
                 </a:solidFill>
                 <a:latin typeface="Calibri"/>
               </a:rPr>
-              <a:t>2 / 6</a:t>
+              <a:t>2 / 7</a:t>
             </a:r>
           </a:p>
         </p:txBody>
@@ -5106,8 +5298,8 @@
         </p:nvSpPr>
         <p:spPr>
           <a:xfrm>
-            <a:off x="11338560" y="6492240"/>
-            <a:ext cx="731520" cy="274320"/>
+            <a:off x="11155680" y="6492240"/>
+            <a:ext cx="914400" cy="274320"/>
           </a:xfrm>
           <a:prstGeom prst="rect">
             <a:avLst/>
@@ -5128,7 +5320,7 @@
                 </a:solidFill>
                 <a:latin typeface="Calibri"/>
               </a:rPr>
-              <a:t>3 / 6</a:t>
+              <a:t>3 / 7</a:t>
             </a:r>
           </a:p>
         </p:txBody>
@@ -5934,8 +6126,8 @@
         </p:nvSpPr>
         <p:spPr>
           <a:xfrm>
-            <a:off x="11338560" y="6492240"/>
-            <a:ext cx="731520" cy="274320"/>
+            <a:off x="11155680" y="6492240"/>
+            <a:ext cx="914400" cy="274320"/>
           </a:xfrm>
           <a:prstGeom prst="rect">
             <a:avLst/>
@@ -5956,7 +6148,7 @@
                 </a:solidFill>
                 <a:latin typeface="Calibri"/>
               </a:rPr>
-              <a:t>4 / 6</a:t>
+              <a:t>4 / 7</a:t>
             </a:r>
           </a:p>
         </p:txBody>
@@ -6383,8 +6575,8 @@
         </p:nvSpPr>
         <p:spPr>
           <a:xfrm>
-            <a:off x="11338560" y="6492240"/>
-            <a:ext cx="731520" cy="274320"/>
+            <a:off x="11155680" y="6492240"/>
+            <a:ext cx="914400" cy="274320"/>
           </a:xfrm>
           <a:prstGeom prst="rect">
             <a:avLst/>
@@ -6405,7 +6597,7 @@
                 </a:solidFill>
                 <a:latin typeface="Calibri"/>
               </a:rPr>
-              <a:t>5 / 6</a:t>
+              <a:t>5 / 7</a:t>
             </a:r>
           </a:p>
         </p:txBody>
@@ -6875,8 +7067,8 @@
         </p:nvSpPr>
         <p:spPr>
           <a:xfrm>
-            <a:off x="11338560" y="6492240"/>
-            <a:ext cx="731520" cy="274320"/>
+            <a:off x="11155680" y="6492240"/>
+            <a:ext cx="914400" cy="274320"/>
           </a:xfrm>
           <a:prstGeom prst="rect">
             <a:avLst/>
@@ -6897,7 +7089,7 @@
                 </a:solidFill>
                 <a:latin typeface="Calibri"/>
               </a:rPr>
-              <a:t>6 / 6</a:t>
+              <a:t>6 / 7</a:t>
             </a:r>
           </a:p>
         </p:txBody>
@@ -7302,6 +7494,953 @@
                 <a:latin typeface="Calibri"/>
               </a:rPr>
               <a:t>“`pip install kage` · 6-layer architecture diagram in `docs/architecture.html`”</a:t>
+            </a:r>
+          </a:p>
+        </p:txBody>
+      </p:sp>
+    </p:spTree>
+  </p:cSld>
+  <p:clrMapOvr>
+    <a:masterClrMapping/>
+  </p:clrMapOvr>
+</p:sld>
+</file>
+
+<file path=ppt/slides/slide7.xml><?xml version="1.0" encoding="utf-8"?>
+<p:sld xmlns:a="http://schemas.openxmlformats.org/drawingml/2006/main" xmlns:p="http://schemas.openxmlformats.org/presentationml/2006/main" xmlns:r="http://schemas.openxmlformats.org/officeDocument/2006/relationships">
+  <p:cSld>
+    <p:bg>
+      <p:bgPr>
+        <a:solidFill>
+          <a:srgbClr val="FFFFFF"/>
+        </a:solidFill>
+        <a:effectLst/>
+      </p:bgPr>
+    </p:bg>
+    <p:spTree>
+      <p:nvGrpSpPr>
+        <p:cNvPr id="1" name=""/>
+        <p:cNvGrpSpPr/>
+        <p:nvPr/>
+      </p:nvGrpSpPr>
+      <p:grpSpPr/>
+      <p:sp>
+        <p:nvSpPr>
+          <p:cNvPr id="2" name="Rectangle 1"/>
+          <p:cNvSpPr/>
+          <p:nvPr/>
+        </p:nvSpPr>
+        <p:spPr>
+          <a:xfrm>
+            <a:off x="0" y="0"/>
+            <a:ext cx="146304" cy="6858000"/>
+          </a:xfrm>
+          <a:prstGeom prst="rect">
+            <a:avLst/>
+          </a:prstGeom>
+          <a:solidFill>
+            <a:srgbClr val="2563EB"/>
+          </a:solidFill>
+          <a:ln>
+            <a:noFill/>
+          </a:ln>
+          <a:effectLst/>
+        </p:spPr>
+        <p:style>
+          <a:lnRef idx="1">
+            <a:schemeClr val="accent1"/>
+          </a:lnRef>
+          <a:fillRef idx="3">
+            <a:schemeClr val="accent1"/>
+          </a:fillRef>
+          <a:effectRef idx="2">
+            <a:schemeClr val="accent1"/>
+          </a:effectRef>
+          <a:fontRef idx="minor">
+            <a:schemeClr val="lt1"/>
+          </a:fontRef>
+        </p:style>
+        <p:txBody>
+          <a:bodyPr rtlCol="0" anchor="ctr"/>
+          <a:lstStyle/>
+          <a:p>
+            <a:pPr algn="ctr"/>
+          </a:p>
+        </p:txBody>
+      </p:sp>
+      <p:sp>
+        <p:nvSpPr>
+          <p:cNvPr id="3" name="TextBox 2"/>
+          <p:cNvSpPr txBox="1"/>
+          <p:nvPr/>
+        </p:nvSpPr>
+        <p:spPr>
+          <a:xfrm>
+            <a:off x="11155680" y="6492240"/>
+            <a:ext cx="914400" cy="274320"/>
+          </a:xfrm>
+          <a:prstGeom prst="rect">
+            <a:avLst/>
+          </a:prstGeom>
+          <a:noFill/>
+        </p:spPr>
+        <p:txBody>
+          <a:bodyPr wrap="square">
+            <a:spAutoFit/>
+          </a:bodyPr>
+          <a:lstStyle/>
+          <a:p>
+            <a:pPr algn="r"/>
+            <a:r>
+              <a:rPr sz="1100" b="0">
+                <a:solidFill>
+                  <a:srgbClr val="6B7280"/>
+                </a:solidFill>
+                <a:latin typeface="Calibri"/>
+              </a:rPr>
+              <a:t>7 / 7</a:t>
+            </a:r>
+          </a:p>
+        </p:txBody>
+      </p:sp>
+      <p:sp>
+        <p:nvSpPr>
+          <p:cNvPr id="4" name="TextBox 3"/>
+          <p:cNvSpPr txBox="1"/>
+          <p:nvPr/>
+        </p:nvSpPr>
+        <p:spPr>
+          <a:xfrm>
+            <a:off x="457200" y="320040"/>
+            <a:ext cx="11430000" cy="640080"/>
+          </a:xfrm>
+          <a:prstGeom prst="rect">
+            <a:avLst/>
+          </a:prstGeom>
+          <a:noFill/>
+        </p:spPr>
+        <p:txBody>
+          <a:bodyPr wrap="square">
+            <a:spAutoFit/>
+          </a:bodyPr>
+          <a:lstStyle/>
+          <a:p>
+            <a:pPr algn="l"/>
+            <a:r>
+              <a:rPr sz="2800" b="1">
+                <a:solidFill>
+                  <a:srgbClr val="1F2937"/>
+                </a:solidFill>
+                <a:latin typeface="Calibri"/>
+              </a:rPr>
+              <a:t>KAGE × Databricks — What KAGE Adds</a:t>
+            </a:r>
+          </a:p>
+        </p:txBody>
+      </p:sp>
+      <p:sp>
+        <p:nvSpPr>
+          <p:cNvPr id="5" name="TextBox 4"/>
+          <p:cNvSpPr txBox="1"/>
+          <p:nvPr/>
+        </p:nvSpPr>
+        <p:spPr>
+          <a:xfrm>
+            <a:off x="457200" y="960120"/>
+            <a:ext cx="11430000" cy="457200"/>
+          </a:xfrm>
+          <a:prstGeom prst="rect">
+            <a:avLst/>
+          </a:prstGeom>
+          <a:noFill/>
+        </p:spPr>
+        <p:txBody>
+          <a:bodyPr wrap="square">
+            <a:spAutoFit/>
+          </a:bodyPr>
+          <a:lstStyle/>
+          <a:p>
+            <a:pPr algn="l"/>
+            <a:r>
+              <a:rPr sz="1600" b="0">
+                <a:solidFill>
+                  <a:srgbClr val="2563EB"/>
+                </a:solidFill>
+                <a:latin typeface="Calibri"/>
+              </a:rPr>
+              <a:t>Extends Databricks observability; does not replace it.</a:t>
+            </a:r>
+          </a:p>
+        </p:txBody>
+      </p:sp>
+      <p:graphicFrame>
+        <p:nvGraphicFramePr>
+          <p:cNvPr id="6" name="kage_databricks_comparison"/>
+          <p:cNvGraphicFramePr>
+            <a:graphicFrameLocks noGrp="1"/>
+          </p:cNvGraphicFramePr>
+          <p:nvPr/>
+        </p:nvGraphicFramePr>
+        <p:xfrm>
+          <a:off x="457200" y="1508760"/>
+          <a:ext cx="11274552" cy="4800600"/>
+        </p:xfrm>
+        <a:graphic>
+          <a:graphicData uri="http://schemas.openxmlformats.org/drawingml/2006/table">
+            <a:tbl>
+              <a:tblPr firstRow="1" bandRow="1">
+                <a:tableStyleId>{5C22544A-7EE6-4342-B048-85BDC9FD1C3A}</a:tableStyleId>
+              </a:tblPr>
+              <a:tblGrid>
+                <a:gridCol w="2743200"/>
+                <a:gridCol w="4206240"/>
+                <a:gridCol w="4325112"/>
+              </a:tblGrid>
+              <a:tr h="480060">
+                <a:tc>
+                  <a:txBody>
+                    <a:bodyPr lIns="73152" rIns="73152" tIns="36576" bIns="36576" wrap="square"/>
+                    <a:lstStyle/>
+                    <a:p>
+                      <a:pPr algn="l"/>
+                      <a:r>
+                        <a:rPr sz="1200" b="1">
+                          <a:solidFill>
+                            <a:srgbClr val="FFFFFF"/>
+                          </a:solidFill>
+                          <a:latin typeface="Calibri"/>
+                        </a:rPr>
+                        <a:t>Capability</a:t>
+                      </a:r>
+                    </a:p>
+                  </a:txBody>
+                  <a:tcPr>
+                    <a:solidFill>
+                      <a:srgbClr val="2563EB"/>
+                    </a:solidFill>
+                  </a:tcPr>
+                </a:tc>
+                <a:tc>
+                  <a:txBody>
+                    <a:bodyPr lIns="73152" rIns="73152" tIns="36576" bIns="36576" wrap="square"/>
+                    <a:lstStyle/>
+                    <a:p>
+                      <a:pPr algn="l"/>
+                      <a:r>
+                        <a:rPr sz="1200" b="1">
+                          <a:solidFill>
+                            <a:srgbClr val="FFFFFF"/>
+                          </a:solidFill>
+                          <a:latin typeface="Calibri"/>
+                        </a:rPr>
+                        <a:t>Databricks today</a:t>
+                      </a:r>
+                    </a:p>
+                  </a:txBody>
+                  <a:tcPr>
+                    <a:solidFill>
+                      <a:srgbClr val="2563EB"/>
+                    </a:solidFill>
+                  </a:tcPr>
+                </a:tc>
+                <a:tc>
+                  <a:txBody>
+                    <a:bodyPr lIns="73152" rIns="73152" tIns="36576" bIns="36576" wrap="square"/>
+                    <a:lstStyle/>
+                    <a:p>
+                      <a:pPr algn="l"/>
+                      <a:r>
+                        <a:rPr sz="1200" b="1">
+                          <a:solidFill>
+                            <a:srgbClr val="FFFFFF"/>
+                          </a:solidFill>
+                          <a:latin typeface="Calibri"/>
+                        </a:rPr>
+                        <a:t>What KAGE adds</a:t>
+                      </a:r>
+                    </a:p>
+                  </a:txBody>
+                  <a:tcPr>
+                    <a:solidFill>
+                      <a:srgbClr val="2563EB"/>
+                    </a:solidFill>
+                  </a:tcPr>
+                </a:tc>
+              </a:tr>
+              <a:tr h="480060">
+                <a:tc>
+                  <a:txBody>
+                    <a:bodyPr lIns="73152" rIns="73152" tIns="36576" bIns="36576" wrap="square"/>
+                    <a:lstStyle/>
+                    <a:p>
+                      <a:pPr algn="l"/>
+                      <a:r>
+                        <a:rPr sz="1000" b="0">
+                          <a:solidFill>
+                            <a:srgbClr val="1F2937"/>
+                          </a:solidFill>
+                          <a:latin typeface="Calibri"/>
+                        </a:rPr>
+                        <a:t>Cross-platform schema</a:t>
+                      </a:r>
+                    </a:p>
+                  </a:txBody>
+                  <a:tcPr>
+                    <a:solidFill>
+                      <a:srgbClr val="FFFFFF"/>
+                    </a:solidFill>
+                  </a:tcPr>
+                </a:tc>
+                <a:tc>
+                  <a:txBody>
+                    <a:bodyPr lIns="73152" rIns="73152" tIns="36576" bIns="36576" wrap="square"/>
+                    <a:lstStyle/>
+                    <a:p>
+                      <a:pPr algn="l"/>
+                      <a:r>
+                        <a:rPr sz="1000" b="0">
+                          <a:solidFill>
+                            <a:srgbClr val="1F2937"/>
+                          </a:solidFill>
+                          <a:latin typeface="Calibri"/>
+                        </a:rPr>
+                        <a:t>Unity Catalog &amp; system tables are Databricks-only</a:t>
+                      </a:r>
+                    </a:p>
+                  </a:txBody>
+                  <a:tcPr>
+                    <a:solidFill>
+                      <a:srgbClr val="FFFFFF"/>
+                    </a:solidFill>
+                  </a:tcPr>
+                </a:tc>
+                <a:tc>
+                  <a:txBody>
+                    <a:bodyPr lIns="73152" rIns="73152" tIns="36576" bIns="36576" wrap="square"/>
+                    <a:lstStyle/>
+                    <a:p>
+                      <a:pPr algn="l"/>
+                      <a:r>
+                        <a:rPr sz="1000" b="0">
+                          <a:solidFill>
+                            <a:srgbClr val="1F2937"/>
+                          </a:solidFill>
+                          <a:latin typeface="Calibri"/>
+                        </a:rPr>
+                        <a:t>One JSONL contract across Spark, Glue, Synapse, Snowflake, dbt, Airflow, plain Python</a:t>
+                      </a:r>
+                    </a:p>
+                  </a:txBody>
+                  <a:tcPr>
+                    <a:solidFill>
+                      <a:srgbClr val="FFFFFF"/>
+                    </a:solidFill>
+                  </a:tcPr>
+                </a:tc>
+              </a:tr>
+              <a:tr h="480060">
+                <a:tc>
+                  <a:txBody>
+                    <a:bodyPr lIns="73152" rIns="73152" tIns="36576" bIns="36576" wrap="square"/>
+                    <a:lstStyle/>
+                    <a:p>
+                      <a:pPr algn="l"/>
+                      <a:r>
+                        <a:rPr sz="1000" b="0">
+                          <a:solidFill>
+                            <a:srgbClr val="1F2937"/>
+                          </a:solidFill>
+                          <a:latin typeface="Calibri"/>
+                        </a:rPr>
+                        <a:t>Medallion as first-class</a:t>
+                      </a:r>
+                    </a:p>
+                  </a:txBody>
+                  <a:tcPr>
+                    <a:solidFill>
+                      <a:srgbClr val="F3F4F6"/>
+                    </a:solidFill>
+                  </a:tcPr>
+                </a:tc>
+                <a:tc>
+                  <a:txBody>
+                    <a:bodyPr lIns="73152" rIns="73152" tIns="36576" bIns="36576" wrap="square"/>
+                    <a:lstStyle/>
+                    <a:p>
+                      <a:pPr algn="l"/>
+                      <a:r>
+                        <a:rPr sz="1000" b="0">
+                          <a:solidFill>
+                            <a:srgbClr val="1F2937"/>
+                          </a:solidFill>
+                          <a:latin typeface="Calibri"/>
+                        </a:rPr>
+                        <a:t>Lineage knows tables, not layers</a:t>
+                      </a:r>
+                    </a:p>
+                  </a:txBody>
+                  <a:tcPr>
+                    <a:solidFill>
+                      <a:srgbClr val="F3F4F6"/>
+                    </a:solidFill>
+                  </a:tcPr>
+                </a:tc>
+                <a:tc>
+                  <a:txBody>
+                    <a:bodyPr lIns="73152" rIns="73152" tIns="36576" bIns="36576" wrap="square"/>
+                    <a:lstStyle/>
+                    <a:p>
+                      <a:pPr algn="l"/>
+                      <a:r>
+                        <a:rPr sz="1000" b="0">
+                          <a:solidFill>
+                            <a:srgbClr val="1F2937"/>
+                          </a:solidFill>
+                          <a:latin typeface="Calibri"/>
+                        </a:rPr>
+                        <a:t>Every event carries `layer` — direct "gold survival %" queries, no joins</a:t>
+                      </a:r>
+                    </a:p>
+                  </a:txBody>
+                  <a:tcPr>
+                    <a:solidFill>
+                      <a:srgbClr val="F3F4F6"/>
+                    </a:solidFill>
+                  </a:tcPr>
+                </a:tc>
+              </a:tr>
+              <a:tr h="480060">
+                <a:tc>
+                  <a:txBody>
+                    <a:bodyPr lIns="73152" rIns="73152" tIns="36576" bIns="36576" wrap="square"/>
+                    <a:lstStyle/>
+                    <a:p>
+                      <a:pPr algn="l"/>
+                      <a:r>
+                        <a:rPr sz="1000" b="0">
+                          <a:solidFill>
+                            <a:srgbClr val="1F2937"/>
+                          </a:solidFill>
+                          <a:latin typeface="Calibri"/>
+                        </a:rPr>
+                        <a:t>You own the storage</a:t>
+                      </a:r>
+                    </a:p>
+                  </a:txBody>
+                  <a:tcPr>
+                    <a:solidFill>
+                      <a:srgbClr val="FFFFFF"/>
+                    </a:solidFill>
+                  </a:tcPr>
+                </a:tc>
+                <a:tc>
+                  <a:txBody>
+                    <a:bodyPr lIns="73152" rIns="73152" tIns="36576" bIns="36576" wrap="square"/>
+                    <a:lstStyle/>
+                    <a:p>
+                      <a:pPr algn="l"/>
+                      <a:r>
+                        <a:rPr sz="1000" b="0">
+                          <a:solidFill>
+                            <a:srgbClr val="1F2937"/>
+                          </a:solidFill>
+                          <a:latin typeface="Calibri"/>
+                        </a:rPr>
+                        <a:t>System tables retained per Databricks policy</a:t>
+                      </a:r>
+                    </a:p>
+                  </a:txBody>
+                  <a:tcPr>
+                    <a:solidFill>
+                      <a:srgbClr val="FFFFFF"/>
+                    </a:solidFill>
+                  </a:tcPr>
+                </a:tc>
+                <a:tc>
+                  <a:txBody>
+                    <a:bodyPr lIns="73152" rIns="73152" tIns="36576" bIns="36576" wrap="square"/>
+                    <a:lstStyle/>
+                    <a:p>
+                      <a:pPr algn="l"/>
+                      <a:r>
+                        <a:rPr sz="1000" b="0">
+                          <a:solidFill>
+                            <a:srgbClr val="1F2937"/>
+                          </a:solidFill>
+                          <a:latin typeface="Calibri"/>
+                        </a:rPr>
+                        <a:t>Plain JSONL in your Volume / S3 / ADLS — your retention, your export</a:t>
+                      </a:r>
+                    </a:p>
+                  </a:txBody>
+                  <a:tcPr>
+                    <a:solidFill>
+                      <a:srgbClr val="FFFFFF"/>
+                    </a:solidFill>
+                  </a:tcPr>
+                </a:tc>
+              </a:tr>
+              <a:tr h="480060">
+                <a:tc>
+                  <a:txBody>
+                    <a:bodyPr lIns="73152" rIns="73152" tIns="36576" bIns="36576" wrap="square"/>
+                    <a:lstStyle/>
+                    <a:p>
+                      <a:pPr algn="l"/>
+                      <a:r>
+                        <a:rPr sz="1000" b="0">
+                          <a:solidFill>
+                            <a:srgbClr val="1F2937"/>
+                          </a:solidFill>
+                          <a:latin typeface="Calibri"/>
+                        </a:rPr>
+                        <a:t>Business custom fields</a:t>
+                      </a:r>
+                    </a:p>
+                  </a:txBody>
+                  <a:tcPr>
+                    <a:solidFill>
+                      <a:srgbClr val="F3F4F6"/>
+                    </a:solidFill>
+                  </a:tcPr>
+                </a:tc>
+                <a:tc>
+                  <a:txBody>
+                    <a:bodyPr lIns="73152" rIns="73152" tIns="36576" bIns="36576" wrap="square"/>
+                    <a:lstStyle/>
+                    <a:p>
+                      <a:pPr algn="l"/>
+                      <a:r>
+                        <a:rPr sz="1000" b="0">
+                          <a:solidFill>
+                            <a:srgbClr val="1F2937"/>
+                          </a:solidFill>
+                          <a:latin typeface="Calibri"/>
+                        </a:rPr>
+                        <a:t>Cluster tags don't reach the event stream</a:t>
+                      </a:r>
+                    </a:p>
+                  </a:txBody>
+                  <a:tcPr>
+                    <a:solidFill>
+                      <a:srgbClr val="F3F4F6"/>
+                    </a:solidFill>
+                  </a:tcPr>
+                </a:tc>
+                <a:tc>
+                  <a:txBody>
+                    <a:bodyPr lIns="73152" rIns="73152" tIns="36576" bIns="36576" wrap="square"/>
+                    <a:lstStyle/>
+                    <a:p>
+                      <a:pPr algn="l"/>
+                      <a:r>
+                        <a:rPr sz="1000" b="0">
+                          <a:solidFill>
+                            <a:srgbClr val="1F2937"/>
+                          </a:solidFill>
+                          <a:latin typeface="Calibri"/>
+                        </a:rPr>
+                        <a:t>`custom_fields={owner, sla_minutes, cost_center}` on every event</a:t>
+                      </a:r>
+                    </a:p>
+                  </a:txBody>
+                  <a:tcPr>
+                    <a:solidFill>
+                      <a:srgbClr val="F3F4F6"/>
+                    </a:solidFill>
+                  </a:tcPr>
+                </a:tc>
+              </a:tr>
+              <a:tr h="480060">
+                <a:tc>
+                  <a:txBody>
+                    <a:bodyPr lIns="73152" rIns="73152" tIns="36576" bIns="36576" wrap="square"/>
+                    <a:lstStyle/>
+                    <a:p>
+                      <a:pPr algn="l"/>
+                      <a:r>
+                        <a:rPr sz="1000" b="0">
+                          <a:solidFill>
+                            <a:srgbClr val="1F2937"/>
+                          </a:solidFill>
+                          <a:latin typeface="Calibri"/>
+                        </a:rPr>
+                        <a:t>Lineage outside Databricks</a:t>
+                      </a:r>
+                    </a:p>
+                  </a:txBody>
+                  <a:tcPr>
+                    <a:solidFill>
+                      <a:srgbClr val="FFFFFF"/>
+                    </a:solidFill>
+                  </a:tcPr>
+                </a:tc>
+                <a:tc>
+                  <a:txBody>
+                    <a:bodyPr lIns="73152" rIns="73152" tIns="36576" bIns="36576" wrap="square"/>
+                    <a:lstStyle/>
+                    <a:p>
+                      <a:pPr algn="l"/>
+                      <a:r>
+                        <a:rPr sz="1000" b="0">
+                          <a:solidFill>
+                            <a:srgbClr val="1F2937"/>
+                          </a:solidFill>
+                          <a:latin typeface="Calibri"/>
+                        </a:rPr>
+                        <a:t>UC lineage requires Databricks reads/writes</a:t>
+                      </a:r>
+                    </a:p>
+                  </a:txBody>
+                  <a:tcPr>
+                    <a:solidFill>
+                      <a:srgbClr val="FFFFFF"/>
+                    </a:solidFill>
+                  </a:tcPr>
+                </a:tc>
+                <a:tc>
+                  <a:txBody>
+                    <a:bodyPr lIns="73152" rIns="73152" tIns="36576" bIns="36576" wrap="square"/>
+                    <a:lstStyle/>
+                    <a:p>
+                      <a:pPr algn="l"/>
+                      <a:r>
+                        <a:rPr sz="1000" b="0">
+                          <a:solidFill>
+                            <a:srgbClr val="1F2937"/>
+                          </a:solidFill>
+                          <a:latin typeface="Calibri"/>
+                        </a:rPr>
+                        <a:t>`upstream_datasets=[...]` works from pandas, dbt, Airflow operators</a:t>
+                      </a:r>
+                    </a:p>
+                  </a:txBody>
+                  <a:tcPr>
+                    <a:solidFill>
+                      <a:srgbClr val="FFFFFF"/>
+                    </a:solidFill>
+                  </a:tcPr>
+                </a:tc>
+              </a:tr>
+              <a:tr h="480060">
+                <a:tc>
+                  <a:txBody>
+                    <a:bodyPr lIns="73152" rIns="73152" tIns="36576" bIns="36576" wrap="square"/>
+                    <a:lstStyle/>
+                    <a:p>
+                      <a:pPr algn="l"/>
+                      <a:r>
+                        <a:rPr sz="1000" b="0">
+                          <a:solidFill>
+                            <a:srgbClr val="1F2937"/>
+                          </a:solidFill>
+                          <a:latin typeface="Calibri"/>
+                        </a:rPr>
+                        <a:t>AI-suggested remediation</a:t>
+                      </a:r>
+                    </a:p>
+                  </a:txBody>
+                  <a:tcPr>
+                    <a:solidFill>
+                      <a:srgbClr val="F3F4F6"/>
+                    </a:solidFill>
+                  </a:tcPr>
+                </a:tc>
+                <a:tc>
+                  <a:txBody>
+                    <a:bodyPr lIns="73152" rIns="73152" tIns="36576" bIns="36576" wrap="square"/>
+                    <a:lstStyle/>
+                    <a:p>
+                      <a:pPr algn="l"/>
+                      <a:r>
+                        <a:rPr sz="1000" b="0">
+                          <a:solidFill>
+                            <a:srgbClr val="1F2937"/>
+                          </a:solidFill>
+                          <a:latin typeface="Calibri"/>
+                        </a:rPr>
+                        <a:t>Not in built-in observability today</a:t>
+                      </a:r>
+                    </a:p>
+                  </a:txBody>
+                  <a:tcPr>
+                    <a:solidFill>
+                      <a:srgbClr val="F3F4F6"/>
+                    </a:solidFill>
+                  </a:tcPr>
+                </a:tc>
+                <a:tc>
+                  <a:txBody>
+                    <a:bodyPr lIns="73152" rIns="73152" tIns="36576" bIns="36576" wrap="square"/>
+                    <a:lstStyle/>
+                    <a:p>
+                      <a:pPr algn="l"/>
+                      <a:r>
+                        <a:rPr sz="1000" b="0">
+                          <a:solidFill>
+                            <a:srgbClr val="1F2937"/>
+                          </a:solidFill>
+                          <a:latin typeface="Calibri"/>
+                        </a:rPr>
+                        <a:t>`ai_query()` column on every analytics SQL — LLM fix per error / bottleneck</a:t>
+                      </a:r>
+                    </a:p>
+                  </a:txBody>
+                  <a:tcPr>
+                    <a:solidFill>
+                      <a:srgbClr val="F3F4F6"/>
+                    </a:solidFill>
+                  </a:tcPr>
+                </a:tc>
+              </a:tr>
+              <a:tr h="480060">
+                <a:tc>
+                  <a:txBody>
+                    <a:bodyPr lIns="73152" rIns="73152" tIns="36576" bIns="36576" wrap="square"/>
+                    <a:lstStyle/>
+                    <a:p>
+                      <a:pPr algn="l"/>
+                      <a:r>
+                        <a:rPr sz="1000" b="0">
+                          <a:solidFill>
+                            <a:srgbClr val="1F2937"/>
+                          </a:solidFill>
+                          <a:latin typeface="Calibri"/>
+                        </a:rPr>
+                        <a:t>Cost attribution by layer</a:t>
+                      </a:r>
+                    </a:p>
+                  </a:txBody>
+                  <a:tcPr>
+                    <a:solidFill>
+                      <a:srgbClr val="FFFFFF"/>
+                    </a:solidFill>
+                  </a:tcPr>
+                </a:tc>
+                <a:tc>
+                  <a:txBody>
+                    <a:bodyPr lIns="73152" rIns="73152" tIns="36576" bIns="36576" wrap="square"/>
+                    <a:lstStyle/>
+                    <a:p>
+                      <a:pPr algn="l"/>
+                      <a:r>
+                        <a:rPr sz="1000" b="0">
+                          <a:solidFill>
+                            <a:srgbClr val="1F2937"/>
+                          </a:solidFill>
+                          <a:latin typeface="Calibri"/>
+                        </a:rPr>
+                        <a:t>Billing is cluster-level</a:t>
+                      </a:r>
+                    </a:p>
+                  </a:txBody>
+                  <a:tcPr>
+                    <a:solidFill>
+                      <a:srgbClr val="FFFFFF"/>
+                    </a:solidFill>
+                  </a:tcPr>
+                </a:tc>
+                <a:tc>
+                  <a:txBody>
+                    <a:bodyPr lIns="73152" rIns="73152" tIns="36576" bIns="36576" wrap="square"/>
+                    <a:lstStyle/>
+                    <a:p>
+                      <a:pPr algn="l"/>
+                      <a:r>
+                        <a:rPr sz="1000" b="0">
+                          <a:solidFill>
+                            <a:srgbClr val="1F2937"/>
+                          </a:solidFill>
+                          <a:latin typeface="Calibri"/>
+                        </a:rPr>
+                        <a:t>Synthetic cost per pipeline × layer × records — chargeback ready</a:t>
+                      </a:r>
+                    </a:p>
+                  </a:txBody>
+                  <a:tcPr>
+                    <a:solidFill>
+                      <a:srgbClr val="FFFFFF"/>
+                    </a:solidFill>
+                  </a:tcPr>
+                </a:tc>
+              </a:tr>
+              <a:tr h="480060">
+                <a:tc>
+                  <a:txBody>
+                    <a:bodyPr lIns="73152" rIns="73152" tIns="36576" bIns="36576" wrap="square"/>
+                    <a:lstStyle/>
+                    <a:p>
+                      <a:pPr algn="l"/>
+                      <a:r>
+                        <a:rPr sz="1000" b="0">
+                          <a:solidFill>
+                            <a:srgbClr val="1F2937"/>
+                          </a:solidFill>
+                          <a:latin typeface="Calibri"/>
+                        </a:rPr>
+                        <a:t>DLT overlay without rewrites</a:t>
+                      </a:r>
+                    </a:p>
+                  </a:txBody>
+                  <a:tcPr>
+                    <a:solidFill>
+                      <a:srgbClr val="F3F4F6"/>
+                    </a:solidFill>
+                  </a:tcPr>
+                </a:tc>
+                <a:tc>
+                  <a:txBody>
+                    <a:bodyPr lIns="73152" rIns="73152" tIns="36576" bIns="36576" wrap="square"/>
+                    <a:lstStyle/>
+                    <a:p>
+                      <a:pPr algn="l"/>
+                      <a:r>
+                        <a:rPr sz="1000" b="0">
+                          <a:solidFill>
+                            <a:srgbClr val="1F2937"/>
+                          </a:solidFill>
+                          <a:latin typeface="Calibri"/>
+                        </a:rPr>
+                        <a:t>DLT metrics are what DLT exposes</a:t>
+                      </a:r>
+                    </a:p>
+                  </a:txBody>
+                  <a:tcPr>
+                    <a:solidFill>
+                      <a:srgbClr val="F3F4F6"/>
+                    </a:solidFill>
+                  </a:tcPr>
+                </a:tc>
+                <a:tc>
+                  <a:txBody>
+                    <a:bodyPr lIns="73152" rIns="73152" tIns="36576" bIns="36576" wrap="square"/>
+                    <a:lstStyle/>
+                    <a:p>
+                      <a:pPr algn="l"/>
+                      <a:r>
+                        <a:rPr sz="1000" b="0">
+                          <a:solidFill>
+                            <a:srgbClr val="1F2937"/>
+                          </a:solidFill>
+                          <a:latin typeface="Calibri"/>
+                        </a:rPr>
+                        <a:t>`@kage_dlt_table` adds your business context at materialization time</a:t>
+                      </a:r>
+                    </a:p>
+                  </a:txBody>
+                  <a:tcPr>
+                    <a:solidFill>
+                      <a:srgbClr val="F3F4F6"/>
+                    </a:solidFill>
+                  </a:tcPr>
+                </a:tc>
+              </a:tr>
+              <a:tr h="480060">
+                <a:tc>
+                  <a:txBody>
+                    <a:bodyPr lIns="73152" rIns="73152" tIns="36576" bIns="36576" wrap="square"/>
+                    <a:lstStyle/>
+                    <a:p>
+                      <a:pPr algn="l"/>
+                      <a:r>
+                        <a:rPr sz="1000" b="0">
+                          <a:solidFill>
+                            <a:srgbClr val="1F2937"/>
+                          </a:solidFill>
+                          <a:latin typeface="Calibri"/>
+                        </a:rPr>
+                        <a:t>Deployment</a:t>
+                      </a:r>
+                    </a:p>
+                  </a:txBody>
+                  <a:tcPr>
+                    <a:solidFill>
+                      <a:srgbClr val="FFFFFF"/>
+                    </a:solidFill>
+                  </a:tcPr>
+                </a:tc>
+                <a:tc>
+                  <a:txBody>
+                    <a:bodyPr lIns="73152" rIns="73152" tIns="36576" bIns="36576" wrap="square"/>
+                    <a:lstStyle/>
+                    <a:p>
+                      <a:pPr algn="l"/>
+                      <a:r>
+                        <a:rPr sz="1000" b="0">
+                          <a:solidFill>
+                            <a:srgbClr val="1F2937"/>
+                          </a:solidFill>
+                          <a:latin typeface="Calibri"/>
+                        </a:rPr>
+                        <a:t>Tied to Databricks runtime</a:t>
+                      </a:r>
+                    </a:p>
+                  </a:txBody>
+                  <a:tcPr>
+                    <a:solidFill>
+                      <a:srgbClr val="FFFFFF"/>
+                    </a:solidFill>
+                  </a:tcPr>
+                </a:tc>
+                <a:tc>
+                  <a:txBody>
+                    <a:bodyPr lIns="73152" rIns="73152" tIns="36576" bIns="36576" wrap="square"/>
+                    <a:lstStyle/>
+                    <a:p>
+                      <a:pPr algn="l"/>
+                      <a:r>
+                        <a:rPr sz="1000" b="0">
+                          <a:solidFill>
+                            <a:srgbClr val="1F2937"/>
+                          </a:solidFill>
+                          <a:latin typeface="Calibri"/>
+                        </a:rPr>
+                        <a:t>`pip install kage` — &lt;10 ms / event, library-only, no agent</a:t>
+                      </a:r>
+                    </a:p>
+                  </a:txBody>
+                  <a:tcPr>
+                    <a:solidFill>
+                      <a:srgbClr val="FFFFFF"/>
+                    </a:solidFill>
+                  </a:tcPr>
+                </a:tc>
+              </a:tr>
+            </a:tbl>
+          </a:graphicData>
+        </a:graphic>
+      </p:graphicFrame>
+      <p:sp>
+        <p:nvSpPr>
+          <p:cNvPr id="7" name="TextBox 6"/>
+          <p:cNvSpPr txBox="1"/>
+          <p:nvPr/>
+        </p:nvSpPr>
+        <p:spPr>
+          <a:xfrm>
+            <a:off x="457200" y="6263640"/>
+            <a:ext cx="11430000" cy="411480"/>
+          </a:xfrm>
+          <a:prstGeom prst="rect">
+            <a:avLst/>
+          </a:prstGeom>
+          <a:noFill/>
+        </p:spPr>
+        <p:txBody>
+          <a:bodyPr wrap="square">
+            <a:spAutoFit/>
+          </a:bodyPr>
+          <a:lstStyle/>
+          <a:p>
+            <a:pPr algn="ctr"/>
+            <a:r>
+              <a:rPr sz="1300" b="0">
+                <a:solidFill>
+                  <a:srgbClr val="6B7280"/>
+                </a:solidFill>
+                <a:latin typeface="Calibri"/>
+              </a:rPr>
+              <a:t>“"Same lens across every platform you run — medallion-aware, AI-augmented."”</a:t>
             </a:r>
           </a:p>
         </p:txBody>

</xml_diff>

<commit_message>
updated architecture and added presentation for kage talk
</commit_message>
<xml_diff>
--- a/presentation/kage_5min.pptx
+++ b/presentation/kage_5min.pptx
@@ -793,7 +793,7 @@
           </a:p>
           <a:p>
             <a:r>
-              <a:t>Tiny surface area, lakehouse-shaped output.</a:t>
+              <a:t>Tiny surface area, lakehouse-shaped output. Two paradigms — ETL **and** agentic — sharing one event stream.</a:t>
             </a:r>
           </a:p>
           <a:p/>
@@ -804,37 +804,37 @@
           </a:p>
           <a:p>
             <a:r>
-              <a:t>1. **3 event types** — that's the entire data model. Easy to remember.</a:t>
-            </a:r>
-          </a:p>
-          <a:p>
-            <a:r>
-              <a:t>2. **2 APIs** — `KageLogger` for explicit control, `@` decorators for</a:t>
-            </a:r>
-          </a:p>
-          <a:p>
-            <a:r>
-              <a:t>   zero-boilerplate. Use either, mix freely.</a:t>
-            </a:r>
-          </a:p>
-          <a:p>
-            <a:r>
-              <a:t>3. **JSONL on disk** — no daemon, no agent, no separate database.</a:t>
-            </a:r>
-          </a:p>
-          <a:p>
-            <a:r>
-              <a:t>4. **Partitioned path** = direct SQL: `SELECT * FROM json.\`…/event_type=job_run/\``.</a:t>
-            </a:r>
-          </a:p>
-          <a:p>
-            <a:r>
-              <a:t>5. **Medallion-aware** — every event carries `layer`, so lineage and</a:t>
-            </a:r>
-          </a:p>
-          <a:p>
-            <a:r>
-              <a:t>   survival-rate metrics fall out for free.</a:t>
+              <a:t>1. **3 event types** — `job_run`, `task_run`, `dataset_event`. The entire data model.</a:t>
+            </a:r>
+          </a:p>
+          <a:p>
+            <a:r>
+              <a:t>2. **Two API flavors** —</a:t>
+            </a:r>
+          </a:p>
+          <a:p>
+            <a:r>
+              <a:t>   - ETL: `@pipeline` / `@task(layer=…)` / `@dataset(layer=…)` for medallion pipelines.</a:t>
+            </a:r>
+          </a:p>
+          <a:p>
+            <a:r>
+              <a:t>   - Agentic: `@agent` / `@step` / `@tool` / `@llm_call` for spans (no medallion required).</a:t>
+            </a:r>
+          </a:p>
+          <a:p>
+            <a:r>
+              <a:t>3. **Four adapters** — DLT, dbt, Airflow, LangChain. Same JSONL output.</a:t>
+            </a:r>
+          </a:p>
+          <a:p>
+            <a:r>
+              <a:t>4. **Core engine** — thread-safe lock for ETL parallelism; `contextvars` span stack for agentic parallelism (asyncio.gather + ThreadPool with copy_context).</a:t>
+            </a:r>
+          </a:p>
+          <a:p>
+            <a:r>
+              <a:t>5. **JSONL on disk** — no daemon, no agent, no separate database. SQL it directly.</a:t>
             </a:r>
           </a:p>
           <a:p/>
@@ -850,7 +850,7 @@
           </a:p>
           <a:p>
             <a:r>
-              <a:t>User Code → API → Core → Transports → Storage → Analytics.</a:t>
+              <a:t>User Code → KAGE API → Adapters → Core Engine → Storage → Analytics.</a:t>
             </a:r>
           </a:p>
           <a:p/>
@@ -5390,7 +5390,7 @@
                 </a:solidFill>
                 <a:latin typeface="Calibri"/>
               </a:rPr>
-              <a:t>3 event types · 2 APIs · 1 lakehouse-ready stream</a:t>
+              <a:t>3 event types · ETL + Agentic APIs · 4 adapters · 1 JSONL stream</a:t>
             </a:r>
           </a:p>
         </p:txBody>
@@ -5457,7 +5457,7 @@
                 </a:solidFill>
                 <a:latin typeface="Calibri"/>
               </a:rPr>
-              <a:t>PySpark · DLT / Lakeflow · dbt · Airflow · Python</a:t>
+              <a:t>PySpark · DLT · dbt · Airflow · LangChain / LangGraph · async agents</a:t>
             </a:r>
           </a:p>
         </p:txBody>
@@ -5560,7 +5560,7 @@
                 </a:solidFill>
                 <a:latin typeface="Calibri"/>
               </a:rPr>
-              <a:t>@pipeline · @task · @dataset · @kage_dlt_table · KageLogger</a:t>
+              <a:t>ETL: @pipeline / @task / @dataset    Agentic: @agent / @step / @tool / @llm_call</a:t>
             </a:r>
           </a:p>
         </p:txBody>
@@ -5603,7 +5603,7 @@
       </p:cxnSp>
       <p:sp>
         <p:nvSpPr>
-          <p:cNvPr id="10" name="layer__Core_Engine"/>
+          <p:cNvPr id="10" name="layer__Adapters"/>
           <p:cNvSpPr/>
           <p:nvPr/>
         </p:nvSpPr>
@@ -5616,7 +5616,7 @@
             <a:avLst/>
           </a:prstGeom>
           <a:solidFill>
-            <a:srgbClr val="EEE9FE"/>
+            <a:srgbClr val="DCFCE7"/>
           </a:solidFill>
           <a:ln w="9525">
             <a:solidFill>
@@ -5651,7 +5651,7 @@
                 </a:solidFill>
                 <a:latin typeface="Calibri"/>
               </a:rPr>
-              <a:t>Core Engine</a:t>
+              <a:t>Adapters</a:t>
             </a:r>
           </a:p>
           <a:p>
@@ -5663,7 +5663,7 @@
                 </a:solidFill>
                 <a:latin typeface="Calibri"/>
               </a:rPr>
-              <a:t>thread-safe · context · schemas (job_run · task_run · dataset_event)</a:t>
+              <a:t>@kage_dlt_table · emit_dbt_run_results · kage_task_callbacks · KageLangChainCallback</a:t>
             </a:r>
           </a:p>
         </p:txBody>
@@ -5706,7 +5706,7 @@
       </p:cxnSp>
       <p:sp>
         <p:nvSpPr>
-          <p:cNvPr id="12" name="layer__Transports"/>
+          <p:cNvPr id="12" name="layer__Core_Engine"/>
           <p:cNvSpPr/>
           <p:nvPr/>
         </p:nvSpPr>
@@ -5719,7 +5719,7 @@
             <a:avLst/>
           </a:prstGeom>
           <a:solidFill>
-            <a:srgbClr val="DCFCE7"/>
+            <a:srgbClr val="EEE9FE"/>
           </a:solidFill>
           <a:ln w="9525">
             <a:solidFill>
@@ -5754,7 +5754,7 @@
                 </a:solidFill>
                 <a:latin typeface="Calibri"/>
               </a:rPr>
-              <a:t>Transports</a:t>
+              <a:t>Core Engine</a:t>
             </a:r>
           </a:p>
           <a:p>
@@ -5766,7 +5766,7 @@
                 </a:solidFill>
                 <a:latin typeface="Calibri"/>
               </a:rPr>
-              <a:t>MultiTransport → FileTransport (JSONL) · StdoutTransport</a:t>
+              <a:t>thread-safe lock · contextvars span stack · auto error capture · schemas</a:t>
             </a:r>
           </a:p>
         </p:txBody>
@@ -5972,7 +5972,7 @@
                 </a:solidFill>
                 <a:latin typeface="Calibri"/>
               </a:rPr>
-              <a:t>SLA · Medallion Health · Lineage · Cost · AI suggestions (ai_query)</a:t>
+              <a:t>SLA · Medallion Health · Lineage · Cost · Agentic call tree · AI suggestions</a:t>
             </a:r>
           </a:p>
         </p:txBody>

</xml_diff>